<commit_message>
verifies asset link if single link is found
</commit_message>
<xml_diff>
--- a/modules/contextualization/cdf_file_annotation/detailed_guides/file-annotation-processing-flow.pptx
+++ b/modules/contextualization/cdf_file_annotation/detailed_guides/file-annotation-processing-flow.pptx
@@ -9,6 +9,7 @@
     <p:sldId id="257" r:id="rId3"/>
     <p:sldId id="258" r:id="rId4"/>
     <p:sldId id="259" r:id="rId5"/>
+    <p:sldId id="260" r:id="rId10"/>
   </p:sldIdLst>
   <p:sldSz cx="12192000" cy="6858000"/>
   <p:notesSz cx="6858000" cy="9144000"/>
@@ -3669,7 +3670,7 @@
                 </a:solidFill>
                 <a:latin typeface="Segoe UI"/>
               </a:rPr>
-              <a:t>Load DetectInDiagrams assets and files. Match text is aliases, or name when aliases are empty.</a:t>
+              <a:t>Group files by scope, then load DetectInDiagrams entities with the same values. Aliases are the match text.</a:t>
             </a:r>
           </a:p>
         </p:txBody>
@@ -5718,7 +5719,7 @@
                 </a:solidFill>
                 <a:latin typeface="Segoe UI"/>
               </a:rPr>
-              <a:t>1 / 4</a:t>
+              <a:t>1 / 5</a:t>
             </a:r>
           </a:p>
         </p:txBody>
@@ -7047,7 +7048,7 @@
                 </a:solidFill>
                 <a:latin typeface="Segoe UI"/>
               </a:rPr>
-              <a:t>1 / 4</a:t>
+              <a:t>1 / 5</a:t>
             </a:r>
           </a:p>
         </p:txBody>
@@ -7253,7 +7254,7 @@
                 </a:solidFill>
                 <a:latin typeface="Segoe UI"/>
               </a:rPr>
-              <a:t>One DetectInDiagrams set is prepared once. patternMode decides whether a second job runs on shapes derived from those aliases.</a:t>
+              <a:t>The entity set is filtered to the file's scope, then prepared once. patternMode decides whether a second job runs.</a:t>
             </a:r>
           </a:p>
         </p:txBody>
@@ -7833,7 +7834,7 @@
                 </a:solidFill>
                 <a:latin typeface="Segoe UI"/>
               </a:rPr>
-              <a:t>Included by tag, matched by alias</a:t>
+              <a:t>Included by tag and scope, matched by alias</a:t>
             </a:r>
           </a:p>
           <a:p>
@@ -7855,7 +7856,7 @@
                 </a:solidFill>
                 <a:latin typeface="Segoe UI"/>
               </a:rPr>
-              <a:t>Asset 23-KA-9101 carries DetectInDiagrams and aliases 23-KA-9101 and VAL_23-KA-9101. A blank alias list falls back to name. An instance with neither is left out of both jobs.</a:t>
+              <a:t>23-KA-9101 needs DetectInDiagrams and the file's site and unit. Aliases 23-KA-9101 and VAL_23-KA-9101 are the match text. A blank alias list falls back to name.</a:t>
             </a:r>
           </a:p>
         </p:txBody>
@@ -8675,7 +8676,7 @@
                 </a:solidFill>
                 <a:latin typeface="Segoe UI"/>
               </a:rPr>
-              <a:t>2 / 4</a:t>
+              <a:t>2 / 5</a:t>
             </a:r>
           </a:p>
         </p:txBody>
@@ -8718,7 +8719,7 @@
                 </a:solidFill>
                 <a:latin typeface="Segoe UI"/>
               </a:rPr>
-              <a:t>2 / 4</a:t>
+              <a:t>2 / 5</a:t>
             </a:r>
           </a:p>
         </p:txBody>
@@ -10313,7 +10314,7 @@
                 </a:solidFill>
                 <a:latin typeface="Segoe UI"/>
               </a:rPr>
-              <a:t>3 / 4</a:t>
+              <a:t>3 / 5</a:t>
             </a:r>
           </a:p>
         </p:txBody>
@@ -10356,7 +10357,7 @@
                 </a:solidFill>
                 <a:latin typeface="Segoe UI"/>
               </a:rPr>
-              <a:t>3 / 4</a:t>
+              <a:t>3 / 5</a:t>
             </a:r>
           </a:p>
         </p:txBody>
@@ -10562,7 +10563,7 @@
                 </a:solidFill>
                 <a:latin typeface="Segoe UI"/>
               </a:rPr>
-              <a:t>A shape hit is not an asset link yet. Promote searches the same aliases and either attaches it or records it as unmatched.</a:t>
+              <a:t>A shape hit is not an asset link yet. Promote searches aliases, and can filter that search to the file's scope.</a:t>
             </a:r>
           </a:p>
         </p:txBody>
@@ -11798,7 +11799,2154 @@
                 </a:solidFill>
                 <a:latin typeface="Segoe UI"/>
               </a:rPr>
-              <a:t>4 / 4</a:t>
+              <a:t>4 / 5</a:t>
+            </a:r>
+          </a:p>
+        </p:txBody>
+      </p:sp>
+    </p:spTree>
+  </p:cSld>
+  <p:clrMapOvr>
+    <a:masterClrMapping/>
+  </p:clrMapOvr>
+</p:sld>
+</file>
+
+<file path=ppt/slides/slide5.xml><?xml version="1.0" encoding="utf-8"?>
+<p:sld xmlns:a="http://schemas.openxmlformats.org/drawingml/2006/main" xmlns:p="http://schemas.openxmlformats.org/presentationml/2006/main" xmlns:r="http://schemas.openxmlformats.org/officeDocument/2006/relationships">
+  <p:cSld>
+    <p:bg>
+      <p:bgPr>
+        <a:solidFill>
+          <a:srgbClr val="F6F4EF"/>
+        </a:solidFill>
+        <a:effectLst/>
+      </p:bgPr>
+    </p:bg>
+    <p:spTree>
+      <p:nvGrpSpPr>
+        <p:cNvPr id="1" name=""/>
+        <p:cNvGrpSpPr/>
+        <p:nvPr/>
+      </p:nvGrpSpPr>
+      <p:grpSpPr/>
+      <p:sp>
+        <p:nvSpPr>
+          <p:cNvPr id="2" name="Rectangle 1"/>
+          <p:cNvSpPr/>
+          <p:nvPr/>
+        </p:nvSpPr>
+        <p:spPr>
+          <a:xfrm>
+            <a:off x="0" y="0"/>
+            <a:ext cx="91440" cy="6858000"/>
+          </a:xfrm>
+          <a:prstGeom prst="rect">
+            <a:avLst/>
+          </a:prstGeom>
+          <a:solidFill>
+            <a:srgbClr val="0E5C52"/>
+          </a:solidFill>
+          <a:ln>
+            <a:noFill/>
+          </a:ln>
+        </p:spPr>
+        <p:style>
+          <a:lnRef idx="1">
+            <a:schemeClr val="accent1"/>
+          </a:lnRef>
+          <a:fillRef idx="3">
+            <a:schemeClr val="accent1"/>
+          </a:fillRef>
+          <a:effectRef idx="2">
+            <a:schemeClr val="accent1"/>
+          </a:effectRef>
+          <a:fontRef idx="minor">
+            <a:schemeClr val="lt1"/>
+          </a:fontRef>
+        </p:style>
+        <p:txBody>
+          <a:bodyPr rtlCol="0" anchor="ctr"/>
+          <a:lstStyle/>
+          <a:p>
+            <a:pPr algn="ctr"/>
+          </a:p>
+        </p:txBody>
+      </p:sp>
+      <p:sp>
+        <p:nvSpPr>
+          <p:cNvPr id="3" name="TextBox 2"/>
+          <p:cNvSpPr txBox="1"/>
+          <p:nvPr/>
+        </p:nvSpPr>
+        <p:spPr>
+          <a:xfrm>
+            <a:off x="384048" y="146304"/>
+            <a:ext cx="11338560" cy="201168"/>
+          </a:xfrm>
+          <a:prstGeom prst="rect">
+            <a:avLst/>
+          </a:prstGeom>
+          <a:noFill/>
+        </p:spPr>
+        <p:txBody>
+          <a:bodyPr wrap="square" lIns="0" rIns="0" tIns="0" bIns="0" anchor="t"/>
+          <a:lstStyle/>
+          <a:p>
+            <a:pPr algn="l">
+              <a:spcBef>
+                <a:spcPts val="0"/>
+              </a:spcBef>
+              <a:spcAft>
+                <a:spcPts val="0"/>
+              </a:spcAft>
+            </a:pPr>
+            <a:r>
+              <a:rPr sz="1100" b="1">
+                <a:solidFill>
+                  <a:srgbClr val="0E5C52"/>
+                </a:solidFill>
+                <a:latin typeface="Segoe UI"/>
+              </a:rPr>
+              <a:t>SCOPE</a:t>
+            </a:r>
+          </a:p>
+        </p:txBody>
+      </p:sp>
+      <p:sp>
+        <p:nvSpPr>
+          <p:cNvPr id="4" name="TextBox 3"/>
+          <p:cNvSpPr txBox="1"/>
+          <p:nvPr/>
+        </p:nvSpPr>
+        <p:spPr>
+          <a:xfrm>
+            <a:off x="384048" y="310896"/>
+            <a:ext cx="11338560" cy="365760"/>
+          </a:xfrm>
+          <a:prstGeom prst="rect">
+            <a:avLst/>
+          </a:prstGeom>
+          <a:noFill/>
+        </p:spPr>
+        <p:txBody>
+          <a:bodyPr wrap="square" lIns="0" rIns="0" tIns="0" bIns="0" anchor="t"/>
+          <a:lstStyle/>
+          <a:p>
+            <a:pPr algn="l">
+              <a:spcBef>
+                <a:spcPts val="0"/>
+              </a:spcBef>
+              <a:spcAft>
+                <a:spcPts val="0"/>
+              </a:spcAft>
+            </a:pPr>
+            <a:r>
+              <a:rPr sz="2600" b="1">
+                <a:solidFill>
+                  <a:srgbClr val="1C2430"/>
+                </a:solidFill>
+                <a:latin typeface="Segoe UI"/>
+              </a:rPr>
+              <a:t>How scope filters the match set</a:t>
+            </a:r>
+          </a:p>
+        </p:txBody>
+      </p:sp>
+      <p:sp>
+        <p:nvSpPr>
+          <p:cNvPr id="5" name="TextBox 4"/>
+          <p:cNvSpPr txBox="1"/>
+          <p:nvPr/>
+        </p:nvSpPr>
+        <p:spPr>
+          <a:xfrm>
+            <a:off x="384048" y="694944"/>
+            <a:ext cx="11338560" cy="292608"/>
+          </a:xfrm>
+          <a:prstGeom prst="rect">
+            <a:avLst/>
+          </a:prstGeom>
+          <a:noFill/>
+        </p:spPr>
+        <p:txBody>
+          <a:bodyPr wrap="square" lIns="0" rIns="0" tIns="0" bIns="0" anchor="t"/>
+          <a:lstStyle/>
+          <a:p>
+            <a:pPr algn="l">
+              <a:spcBef>
+                <a:spcPts val="0"/>
+              </a:spcBef>
+              <a:spcAft>
+                <a:spcPts val="0"/>
+              </a:spcAft>
+            </a:pPr>
+            <a:r>
+              <a:rPr sz="1400" b="0">
+                <a:solidFill>
+                  <a:srgbClr val="5C6570"/>
+                </a:solidFill>
+                <a:latin typeface="Segoe UI"/>
+              </a:rPr>
+              <a:t>primaryScopeProperty and secondaryScopeProperty are property names. The value is read from each file, asset, and reference file.</a:t>
+            </a:r>
+          </a:p>
+        </p:txBody>
+      </p:sp>
+      <p:sp>
+        <p:nvSpPr>
+          <p:cNvPr id="6" name="Rectangle 5"/>
+          <p:cNvSpPr/>
+          <p:nvPr/>
+        </p:nvSpPr>
+        <p:spPr>
+          <a:xfrm>
+            <a:off x="384048" y="1060704"/>
+            <a:ext cx="2788920" cy="292608"/>
+          </a:xfrm>
+          <a:prstGeom prst="rect">
+            <a:avLst/>
+          </a:prstGeom>
+          <a:solidFill>
+            <a:srgbClr val="FFFFFF"/>
+          </a:solidFill>
+          <a:ln w="12700">
+            <a:solidFill>
+              <a:srgbClr val="E2DCD2"/>
+            </a:solidFill>
+          </a:ln>
+        </p:spPr>
+        <p:style>
+          <a:lnRef idx="1">
+            <a:schemeClr val="accent1"/>
+          </a:lnRef>
+          <a:fillRef idx="3">
+            <a:schemeClr val="accent1"/>
+          </a:fillRef>
+          <a:effectRef idx="2">
+            <a:schemeClr val="accent1"/>
+          </a:effectRef>
+          <a:fontRef idx="minor">
+            <a:schemeClr val="lt1"/>
+          </a:fontRef>
+        </p:style>
+        <p:txBody>
+          <a:bodyPr rtlCol="0" anchor="ctr"/>
+          <a:lstStyle/>
+          <a:p>
+            <a:pPr algn="ctr"/>
+          </a:p>
+        </p:txBody>
+      </p:sp>
+      <p:sp>
+        <p:nvSpPr>
+          <p:cNvPr id="7" name="TextBox 6"/>
+          <p:cNvSpPr txBox="1"/>
+          <p:nvPr/>
+        </p:nvSpPr>
+        <p:spPr>
+          <a:xfrm>
+            <a:off x="475488" y="1097280"/>
+            <a:ext cx="2624327" cy="219456"/>
+          </a:xfrm>
+          <a:prstGeom prst="rect">
+            <a:avLst/>
+          </a:prstGeom>
+          <a:noFill/>
+        </p:spPr>
+        <p:txBody>
+          <a:bodyPr wrap="square" lIns="0" rIns="0" tIns="0" bIns="0" anchor="ctr"/>
+          <a:lstStyle/>
+          <a:p>
+            <a:pPr algn="l">
+              <a:spcBef>
+                <a:spcPts val="0"/>
+              </a:spcBef>
+              <a:spcAft>
+                <a:spcPts val="0"/>
+              </a:spcAft>
+            </a:pPr>
+            <a:r>
+              <a:rPr sz="1100" b="1">
+                <a:solidFill>
+                  <a:srgbClr val="3D4754"/>
+                </a:solidFill>
+                <a:latin typeface="Segoe UI"/>
+              </a:rPr>
+              <a:t>primaryScopeProperty: site</a:t>
+            </a:r>
+          </a:p>
+        </p:txBody>
+      </p:sp>
+      <p:sp>
+        <p:nvSpPr>
+          <p:cNvPr id="8" name="Rectangle 7"/>
+          <p:cNvSpPr/>
+          <p:nvPr/>
+        </p:nvSpPr>
+        <p:spPr>
+          <a:xfrm>
+            <a:off x="3282696" y="1060704"/>
+            <a:ext cx="3108960" cy="292608"/>
+          </a:xfrm>
+          <a:prstGeom prst="rect">
+            <a:avLst/>
+          </a:prstGeom>
+          <a:solidFill>
+            <a:srgbClr val="FFFFFF"/>
+          </a:solidFill>
+          <a:ln w="12700">
+            <a:solidFill>
+              <a:srgbClr val="E2DCD2"/>
+            </a:solidFill>
+          </a:ln>
+        </p:spPr>
+        <p:style>
+          <a:lnRef idx="1">
+            <a:schemeClr val="accent1"/>
+          </a:lnRef>
+          <a:fillRef idx="3">
+            <a:schemeClr val="accent1"/>
+          </a:fillRef>
+          <a:effectRef idx="2">
+            <a:schemeClr val="accent1"/>
+          </a:effectRef>
+          <a:fontRef idx="minor">
+            <a:schemeClr val="lt1"/>
+          </a:fontRef>
+        </p:style>
+        <p:txBody>
+          <a:bodyPr rtlCol="0" anchor="ctr"/>
+          <a:lstStyle/>
+          <a:p>
+            <a:pPr algn="ctr"/>
+          </a:p>
+        </p:txBody>
+      </p:sp>
+      <p:sp>
+        <p:nvSpPr>
+          <p:cNvPr id="9" name="TextBox 8"/>
+          <p:cNvSpPr txBox="1"/>
+          <p:nvPr/>
+        </p:nvSpPr>
+        <p:spPr>
+          <a:xfrm>
+            <a:off x="3374136" y="1097280"/>
+            <a:ext cx="2944368" cy="219456"/>
+          </a:xfrm>
+          <a:prstGeom prst="rect">
+            <a:avLst/>
+          </a:prstGeom>
+          <a:noFill/>
+        </p:spPr>
+        <p:txBody>
+          <a:bodyPr wrap="square" lIns="0" rIns="0" tIns="0" bIns="0" anchor="ctr"/>
+          <a:lstStyle/>
+          <a:p>
+            <a:pPr algn="l">
+              <a:spcBef>
+                <a:spcPts val="0"/>
+              </a:spcBef>
+              <a:spcAft>
+                <a:spcPts val="0"/>
+              </a:spcAft>
+            </a:pPr>
+            <a:r>
+              <a:rPr sz="1100" b="1">
+                <a:solidFill>
+                  <a:srgbClr val="3D4754"/>
+                </a:solidFill>
+                <a:latin typeface="Segoe UI"/>
+              </a:rPr>
+              <a:t>secondaryScopeProperty: unit</a:t>
+            </a:r>
+          </a:p>
+        </p:txBody>
+      </p:sp>
+      <p:sp>
+        <p:nvSpPr>
+          <p:cNvPr id="10" name="Rectangle 9"/>
+          <p:cNvSpPr/>
+          <p:nvPr/>
+        </p:nvSpPr>
+        <p:spPr>
+          <a:xfrm>
+            <a:off x="6501384" y="1060704"/>
+            <a:ext cx="2331720" cy="292608"/>
+          </a:xfrm>
+          <a:prstGeom prst="rect">
+            <a:avLst/>
+          </a:prstGeom>
+          <a:solidFill>
+            <a:srgbClr val="FFFFFF"/>
+          </a:solidFill>
+          <a:ln w="12700">
+            <a:solidFill>
+              <a:srgbClr val="E2DCD2"/>
+            </a:solidFill>
+          </a:ln>
+        </p:spPr>
+        <p:style>
+          <a:lnRef idx="1">
+            <a:schemeClr val="accent1"/>
+          </a:lnRef>
+          <a:fillRef idx="3">
+            <a:schemeClr val="accent1"/>
+          </a:fillRef>
+          <a:effectRef idx="2">
+            <a:schemeClr val="accent1"/>
+          </a:effectRef>
+          <a:fontRef idx="minor">
+            <a:schemeClr val="lt1"/>
+          </a:fontRef>
+        </p:style>
+        <p:txBody>
+          <a:bodyPr rtlCol="0" anchor="ctr"/>
+          <a:lstStyle/>
+          <a:p>
+            <a:pPr algn="ctr"/>
+          </a:p>
+        </p:txBody>
+      </p:sp>
+      <p:sp>
+        <p:nvSpPr>
+          <p:cNvPr id="11" name="TextBox 10"/>
+          <p:cNvSpPr txBox="1"/>
+          <p:nvPr/>
+        </p:nvSpPr>
+        <p:spPr>
+          <a:xfrm>
+            <a:off x="6592824" y="1097280"/>
+            <a:ext cx="2167127" cy="219456"/>
+          </a:xfrm>
+          <a:prstGeom prst="rect">
+            <a:avLst/>
+          </a:prstGeom>
+          <a:noFill/>
+        </p:spPr>
+        <p:txBody>
+          <a:bodyPr wrap="square" lIns="0" rIns="0" tIns="0" bIns="0" anchor="ctr"/>
+          <a:lstStyle/>
+          <a:p>
+            <a:pPr algn="l">
+              <a:spcBef>
+                <a:spcPts val="0"/>
+              </a:spcBef>
+              <a:spcAft>
+                <a:spcPts val="0"/>
+              </a:spcAft>
+            </a:pPr>
+            <a:r>
+              <a:rPr sz="1100" b="1">
+                <a:solidFill>
+                  <a:srgbClr val="3D4754"/>
+                </a:solidFill>
+                <a:latin typeface="Segoe UI"/>
+              </a:rPr>
+              <a:t>Empty string disables a level</a:t>
+            </a:r>
+          </a:p>
+        </p:txBody>
+      </p:sp>
+      <p:sp>
+        <p:nvSpPr>
+          <p:cNvPr id="12" name="Rectangle 11"/>
+          <p:cNvSpPr/>
+          <p:nvPr/>
+        </p:nvSpPr>
+        <p:spPr>
+          <a:xfrm>
+            <a:off x="8942832" y="1060704"/>
+            <a:ext cx="2852928" cy="292608"/>
+          </a:xfrm>
+          <a:prstGeom prst="rect">
+            <a:avLst/>
+          </a:prstGeom>
+          <a:solidFill>
+            <a:srgbClr val="FFFFFF"/>
+          </a:solidFill>
+          <a:ln w="12700">
+            <a:solidFill>
+              <a:srgbClr val="E2DCD2"/>
+            </a:solidFill>
+          </a:ln>
+        </p:spPr>
+        <p:style>
+          <a:lnRef idx="1">
+            <a:schemeClr val="accent1"/>
+          </a:lnRef>
+          <a:fillRef idx="3">
+            <a:schemeClr val="accent1"/>
+          </a:fillRef>
+          <a:effectRef idx="2">
+            <a:schemeClr val="accent1"/>
+          </a:effectRef>
+          <a:fontRef idx="minor">
+            <a:schemeClr val="lt1"/>
+          </a:fontRef>
+        </p:style>
+        <p:txBody>
+          <a:bodyPr rtlCol="0" anchor="ctr"/>
+          <a:lstStyle/>
+          <a:p>
+            <a:pPr algn="ctr"/>
+          </a:p>
+        </p:txBody>
+      </p:sp>
+      <p:sp>
+        <p:nvSpPr>
+          <p:cNvPr id="13" name="TextBox 12"/>
+          <p:cNvSpPr txBox="1"/>
+          <p:nvPr/>
+        </p:nvSpPr>
+        <p:spPr>
+          <a:xfrm>
+            <a:off x="9034272" y="1097280"/>
+            <a:ext cx="2688336" cy="219456"/>
+          </a:xfrm>
+          <a:prstGeom prst="rect">
+            <a:avLst/>
+          </a:prstGeom>
+          <a:noFill/>
+        </p:spPr>
+        <p:txBody>
+          <a:bodyPr wrap="square" lIns="0" rIns="0" tIns="0" bIns="0" anchor="ctr"/>
+          <a:lstStyle/>
+          <a:p>
+            <a:pPr algn="l">
+              <a:spcBef>
+                <a:spcPts val="0"/>
+              </a:spcBef>
+              <a:spcAft>
+                <a:spcPts val="0"/>
+              </a:spcAft>
+            </a:pPr>
+            <a:r>
+              <a:rPr sz="1100" b="1">
+                <a:solidFill>
+                  <a:srgbClr val="3D4754"/>
+                </a:solidFill>
+                <a:latin typeface="Segoe UI"/>
+              </a:rPr>
+              <a:t>Promote filter defaults to false</a:t>
+            </a:r>
+          </a:p>
+        </p:txBody>
+      </p:sp>
+      <p:sp>
+        <p:nvSpPr>
+          <p:cNvPr id="14" name="Rectangle 13"/>
+          <p:cNvSpPr/>
+          <p:nvPr/>
+        </p:nvSpPr>
+        <p:spPr>
+          <a:xfrm>
+            <a:off x="384048" y="1499616"/>
+            <a:ext cx="4114800" cy="4901184"/>
+          </a:xfrm>
+          <a:prstGeom prst="rect">
+            <a:avLst/>
+          </a:prstGeom>
+          <a:solidFill>
+            <a:srgbClr val="FFFFFF"/>
+          </a:solidFill>
+          <a:ln w="12700">
+            <a:solidFill>
+              <a:srgbClr val="E2DCD2"/>
+            </a:solidFill>
+          </a:ln>
+        </p:spPr>
+        <p:style>
+          <a:lnRef idx="1">
+            <a:schemeClr val="accent1"/>
+          </a:lnRef>
+          <a:fillRef idx="3">
+            <a:schemeClr val="accent1"/>
+          </a:fillRef>
+          <a:effectRef idx="2">
+            <a:schemeClr val="accent1"/>
+          </a:effectRef>
+          <a:fontRef idx="minor">
+            <a:schemeClr val="lt1"/>
+          </a:fontRef>
+        </p:style>
+        <p:txBody>
+          <a:bodyPr rtlCol="0" anchor="ctr"/>
+          <a:lstStyle/>
+          <a:p>
+            <a:pPr algn="ctr"/>
+          </a:p>
+        </p:txBody>
+      </p:sp>
+      <p:sp>
+        <p:nvSpPr>
+          <p:cNvPr id="15" name="Rectangle 14"/>
+          <p:cNvSpPr/>
+          <p:nvPr/>
+        </p:nvSpPr>
+        <p:spPr>
+          <a:xfrm>
+            <a:off x="384048" y="1499616"/>
+            <a:ext cx="73152" cy="4901184"/>
+          </a:xfrm>
+          <a:prstGeom prst="rect">
+            <a:avLst/>
+          </a:prstGeom>
+          <a:solidFill>
+            <a:srgbClr val="3D4754"/>
+          </a:solidFill>
+          <a:ln>
+            <a:noFill/>
+          </a:ln>
+        </p:spPr>
+        <p:style>
+          <a:lnRef idx="1">
+            <a:schemeClr val="accent1"/>
+          </a:lnRef>
+          <a:fillRef idx="3">
+            <a:schemeClr val="accent1"/>
+          </a:fillRef>
+          <a:effectRef idx="2">
+            <a:schemeClr val="accent1"/>
+          </a:effectRef>
+          <a:fontRef idx="minor">
+            <a:schemeClr val="lt1"/>
+          </a:fontRef>
+        </p:style>
+        <p:txBody>
+          <a:bodyPr rtlCol="0" anchor="ctr"/>
+          <a:lstStyle/>
+          <a:p>
+            <a:pPr algn="ctr"/>
+          </a:p>
+        </p:txBody>
+      </p:sp>
+      <p:sp>
+        <p:nvSpPr>
+          <p:cNvPr id="16" name="TextBox 15"/>
+          <p:cNvSpPr txBox="1"/>
+          <p:nvPr/>
+        </p:nvSpPr>
+        <p:spPr>
+          <a:xfrm>
+            <a:off x="603504" y="1627632"/>
+            <a:ext cx="3730752" cy="4617720"/>
+          </a:xfrm>
+          <a:prstGeom prst="rect">
+            <a:avLst/>
+          </a:prstGeom>
+          <a:noFill/>
+        </p:spPr>
+        <p:txBody>
+          <a:bodyPr wrap="square" lIns="0" rIns="0" tIns="0" bIns="0" anchor="t"/>
+          <a:lstStyle/>
+          <a:p>
+            <a:pPr algn="l">
+              <a:spcBef>
+                <a:spcPts val="0"/>
+              </a:spcBef>
+              <a:spcAft>
+                <a:spcPts val="0"/>
+              </a:spcAft>
+            </a:pPr>
+            <a:r>
+              <a:rPr sz="1500" b="1">
+                <a:solidFill>
+                  <a:srgbClr val="1C2430"/>
+                </a:solidFill>
+                <a:latin typeface="Segoe UI"/>
+              </a:rPr>
+              <a:t>Required on the instances</a:t>
+            </a:r>
+          </a:p>
+          <a:p>
+            <a:pPr algn="l">
+              <a:spcBef>
+                <a:spcPts val="1000"/>
+              </a:spcBef>
+              <a:spcAft>
+                <a:spcPts val="0"/>
+              </a:spcAft>
+            </a:pPr>
+            <a:r>
+              <a:rPr sz="1200" b="0">
+                <a:solidFill>
+                  <a:srgbClr val="1C2430"/>
+                </a:solidFill>
+                <a:latin typeface="Segoe UI"/>
+              </a:rPr>
+              <a:t>Same text property on the file view and the target entity view. Core CogniteFile and CogniteAsset need an extended view that adds it.</a:t>
+            </a:r>
+          </a:p>
+          <a:p>
+            <a:pPr algn="l">
+              <a:spcBef>
+                <a:spcPts val="1200"/>
+              </a:spcBef>
+              <a:spcAft>
+                <a:spcPts val="0"/>
+              </a:spcAft>
+            </a:pPr>
+            <a:r>
+              <a:rPr sz="1300" b="1">
+                <a:solidFill>
+                  <a:srgbClr val="0E5C52"/>
+                </a:solidFill>
+                <a:latin typeface="Segoe UI"/>
+              </a:rPr>
+              <a:t>ToAnnotate file</a:t>
+            </a:r>
+          </a:p>
+          <a:p>
+            <a:pPr algn="l">
+              <a:spcBef>
+                <a:spcPts val="200"/>
+              </a:spcBef>
+              <a:spcAft>
+                <a:spcPts val="0"/>
+              </a:spcAft>
+            </a:pPr>
+            <a:r>
+              <a:rPr sz="1200" b="0">
+                <a:solidFill>
+                  <a:srgbClr val="1C2430"/>
+                </a:solidFill>
+                <a:latin typeface="Segoe UI"/>
+              </a:rPr>
+              <a:t>Carries a value for each configured property. A blank primary value matches every tagged entity. A blank secondary value widens the file to the whole primary scope.</a:t>
+            </a:r>
+          </a:p>
+          <a:p>
+            <a:pPr algn="l">
+              <a:spcBef>
+                <a:spcPts val="1200"/>
+              </a:spcBef>
+              <a:spcAft>
+                <a:spcPts val="0"/>
+              </a:spcAft>
+            </a:pPr>
+            <a:r>
+              <a:rPr sz="1300" b="1">
+                <a:solidFill>
+                  <a:srgbClr val="0E5C52"/>
+                </a:solidFill>
+                <a:latin typeface="Segoe UI"/>
+              </a:rPr>
+              <a:t>DetectInDiagrams asset or file</a:t>
+            </a:r>
+          </a:p>
+          <a:p>
+            <a:pPr algn="l">
+              <a:spcBef>
+                <a:spcPts val="200"/>
+              </a:spcBef>
+              <a:spcAft>
+                <a:spcPts val="0"/>
+              </a:spcAft>
+            </a:pPr>
+            <a:r>
+              <a:rPr sz="1200" b="0">
+                <a:solidFill>
+                  <a:srgbClr val="1C2430"/>
+                </a:solidFill>
+                <a:latin typeface="Segoe UI"/>
+              </a:rPr>
+              <a:t>Carries the same primary and secondary values as the file being annotated. Without those values, no scoped file sees it.</a:t>
+            </a:r>
+          </a:p>
+          <a:p>
+            <a:pPr algn="l">
+              <a:spcBef>
+                <a:spcPts val="1200"/>
+              </a:spcBef>
+              <a:spcAft>
+                <a:spcPts val="0"/>
+              </a:spcAft>
+            </a:pPr>
+            <a:r>
+              <a:rPr sz="1300" b="1">
+                <a:solidFill>
+                  <a:srgbClr val="0E5C52"/>
+                </a:solidFill>
+                <a:latin typeface="Segoe UI"/>
+              </a:rPr>
+              <a:t>ScopeWideDetect asset or file</a:t>
+            </a:r>
+          </a:p>
+          <a:p>
+            <a:pPr algn="l">
+              <a:spcBef>
+                <a:spcPts val="200"/>
+              </a:spcBef>
+              <a:spcAft>
+                <a:spcPts val="0"/>
+              </a:spcAft>
+            </a:pPr>
+            <a:r>
+              <a:rPr sz="1200" b="0">
+                <a:solidFill>
+                  <a:srgbClr val="1C2430"/>
+                </a:solidFill>
+                <a:latin typeface="Segoe UI"/>
+              </a:rPr>
+              <a:t>Carries the same primary value. The secondary value may differ. It stays inside that primary value, so a PlantA entity is out of every PlantB batch.</a:t>
+            </a:r>
+          </a:p>
+        </p:txBody>
+      </p:sp>
+      <p:sp>
+        <p:nvSpPr>
+          <p:cNvPr id="17" name="Rectangle 16"/>
+          <p:cNvSpPr/>
+          <p:nvPr/>
+        </p:nvSpPr>
+        <p:spPr>
+          <a:xfrm>
+            <a:off x="4663440" y="1499616"/>
+            <a:ext cx="7132320" cy="2944368"/>
+          </a:xfrm>
+          <a:prstGeom prst="rect">
+            <a:avLst/>
+          </a:prstGeom>
+          <a:solidFill>
+            <a:srgbClr val="E4F2EE"/>
+          </a:solidFill>
+          <a:ln w="12700">
+            <a:solidFill>
+              <a:srgbClr val="E2DCD2"/>
+            </a:solidFill>
+          </a:ln>
+        </p:spPr>
+        <p:style>
+          <a:lnRef idx="1">
+            <a:schemeClr val="accent1"/>
+          </a:lnRef>
+          <a:fillRef idx="3">
+            <a:schemeClr val="accent1"/>
+          </a:fillRef>
+          <a:effectRef idx="2">
+            <a:schemeClr val="accent1"/>
+          </a:effectRef>
+          <a:fontRef idx="minor">
+            <a:schemeClr val="lt1"/>
+          </a:fontRef>
+        </p:style>
+        <p:txBody>
+          <a:bodyPr rtlCol="0" anchor="ctr"/>
+          <a:lstStyle/>
+          <a:p>
+            <a:pPr algn="ctr"/>
+          </a:p>
+        </p:txBody>
+      </p:sp>
+      <p:sp>
+        <p:nvSpPr>
+          <p:cNvPr id="18" name="Rectangle 17"/>
+          <p:cNvSpPr/>
+          <p:nvPr/>
+        </p:nvSpPr>
+        <p:spPr>
+          <a:xfrm>
+            <a:off x="4663440" y="1499616"/>
+            <a:ext cx="73152" cy="2944368"/>
+          </a:xfrm>
+          <a:prstGeom prst="rect">
+            <a:avLst/>
+          </a:prstGeom>
+          <a:solidFill>
+            <a:srgbClr val="0E5C52"/>
+          </a:solidFill>
+          <a:ln>
+            <a:noFill/>
+          </a:ln>
+        </p:spPr>
+        <p:style>
+          <a:lnRef idx="1">
+            <a:schemeClr val="accent1"/>
+          </a:lnRef>
+          <a:fillRef idx="3">
+            <a:schemeClr val="accent1"/>
+          </a:fillRef>
+          <a:effectRef idx="2">
+            <a:schemeClr val="accent1"/>
+          </a:effectRef>
+          <a:fontRef idx="minor">
+            <a:schemeClr val="lt1"/>
+          </a:fontRef>
+        </p:style>
+        <p:txBody>
+          <a:bodyPr rtlCol="0" anchor="ctr"/>
+          <a:lstStyle/>
+          <a:p>
+            <a:pPr algn="ctr"/>
+          </a:p>
+        </p:txBody>
+      </p:sp>
+      <p:sp>
+        <p:nvSpPr>
+          <p:cNvPr id="19" name="TextBox 18"/>
+          <p:cNvSpPr txBox="1"/>
+          <p:nvPr/>
+        </p:nvSpPr>
+        <p:spPr>
+          <a:xfrm>
+            <a:off x="4882896" y="1591056"/>
+            <a:ext cx="6766560" cy="640080"/>
+          </a:xfrm>
+          <a:prstGeom prst="rect">
+            <a:avLst/>
+          </a:prstGeom>
+          <a:noFill/>
+        </p:spPr>
+        <p:txBody>
+          <a:bodyPr wrap="square" lIns="0" rIns="0" tIns="0" bIns="0" anchor="t"/>
+          <a:lstStyle/>
+          <a:p>
+            <a:pPr algn="l">
+              <a:spcBef>
+                <a:spcPts val="0"/>
+              </a:spcBef>
+              <a:spcAft>
+                <a:spcPts val="0"/>
+              </a:spcAft>
+            </a:pPr>
+            <a:r>
+              <a:rPr sz="1400" b="1">
+                <a:solidFill>
+                  <a:srgbClr val="0E5C52"/>
+                </a:solidFill>
+                <a:latin typeface="Segoe UI"/>
+              </a:rPr>
+              <a:t>Launch  ·  in memory, whenever the names are set</a:t>
+            </a:r>
+          </a:p>
+          <a:p>
+            <a:pPr algn="l">
+              <a:spcBef>
+                <a:spcPts val="200"/>
+              </a:spcBef>
+              <a:spcAft>
+                <a:spcPts val="0"/>
+              </a:spcAft>
+            </a:pPr>
+            <a:r>
+              <a:rPr sz="1200" b="0">
+                <a:solidFill>
+                  <a:srgbClr val="1C2430"/>
+                </a:solidFill>
+                <a:latin typeface="Segoe UI"/>
+              </a:rPr>
+              <a:t>Files that share site and unit form one batch. An entity is included when site equals the file, and either tag below is true.</a:t>
+            </a:r>
+          </a:p>
+        </p:txBody>
+      </p:sp>
+      <p:sp>
+        <p:nvSpPr>
+          <p:cNvPr id="20" name="Rectangle 19"/>
+          <p:cNvSpPr/>
+          <p:nvPr/>
+        </p:nvSpPr>
+        <p:spPr>
+          <a:xfrm>
+            <a:off x="4882896" y="2286000"/>
+            <a:ext cx="6729984" cy="420624"/>
+          </a:xfrm>
+          <a:prstGeom prst="rect">
+            <a:avLst/>
+          </a:prstGeom>
+          <a:solidFill>
+            <a:srgbClr val="FFFFFF"/>
+          </a:solidFill>
+          <a:ln w="12700">
+            <a:solidFill>
+              <a:srgbClr val="E2DCD2"/>
+            </a:solidFill>
+          </a:ln>
+        </p:spPr>
+        <p:style>
+          <a:lnRef idx="1">
+            <a:schemeClr val="accent1"/>
+          </a:lnRef>
+          <a:fillRef idx="3">
+            <a:schemeClr val="accent1"/>
+          </a:fillRef>
+          <a:effectRef idx="2">
+            <a:schemeClr val="accent1"/>
+          </a:effectRef>
+          <a:fontRef idx="minor">
+            <a:schemeClr val="lt1"/>
+          </a:fontRef>
+        </p:style>
+        <p:txBody>
+          <a:bodyPr rtlCol="0" anchor="ctr"/>
+          <a:lstStyle/>
+          <a:p>
+            <a:pPr algn="ctr"/>
+          </a:p>
+        </p:txBody>
+      </p:sp>
+      <p:sp>
+        <p:nvSpPr>
+          <p:cNvPr id="21" name="TextBox 20"/>
+          <p:cNvSpPr txBox="1"/>
+          <p:nvPr/>
+        </p:nvSpPr>
+        <p:spPr>
+          <a:xfrm>
+            <a:off x="4992624" y="2322576"/>
+            <a:ext cx="6510528" cy="365760"/>
+          </a:xfrm>
+          <a:prstGeom prst="rect">
+            <a:avLst/>
+          </a:prstGeom>
+          <a:noFill/>
+        </p:spPr>
+        <p:txBody>
+          <a:bodyPr wrap="square" lIns="0" rIns="0" tIns="0" bIns="0" anchor="ctr"/>
+          <a:lstStyle/>
+          <a:p>
+            <a:pPr algn="l">
+              <a:spcBef>
+                <a:spcPts val="0"/>
+              </a:spcBef>
+              <a:spcAft>
+                <a:spcPts val="0"/>
+              </a:spcAft>
+            </a:pPr>
+            <a:r>
+              <a:rPr sz="1200" b="1">
+                <a:solidFill>
+                  <a:srgbClr val="1C2430"/>
+                </a:solidFill>
+                <a:latin typeface="Segoe UI"/>
+              </a:rPr>
+              <a:t>site matches  AND  (ScopeWideDetect  OR  DetectInDiagrams with the same unit)</a:t>
+            </a:r>
+          </a:p>
+        </p:txBody>
+      </p:sp>
+      <p:sp>
+        <p:nvSpPr>
+          <p:cNvPr id="22" name="TextBox 21"/>
+          <p:cNvSpPr txBox="1"/>
+          <p:nvPr/>
+        </p:nvSpPr>
+        <p:spPr>
+          <a:xfrm>
+            <a:off x="4882896" y="2761488"/>
+            <a:ext cx="6729984" cy="219456"/>
+          </a:xfrm>
+          <a:prstGeom prst="rect">
+            <a:avLst/>
+          </a:prstGeom>
+          <a:noFill/>
+        </p:spPr>
+        <p:txBody>
+          <a:bodyPr wrap="square" lIns="0" rIns="0" tIns="0" bIns="0" anchor="t"/>
+          <a:lstStyle/>
+          <a:p>
+            <a:pPr algn="l">
+              <a:spcBef>
+                <a:spcPts val="0"/>
+              </a:spcBef>
+              <a:spcAft>
+                <a:spcPts val="0"/>
+              </a:spcAft>
+            </a:pPr>
+            <a:r>
+              <a:rPr sz="1200" b="1">
+                <a:solidFill>
+                  <a:srgbClr val="3D4754"/>
+                </a:solidFill>
+                <a:latin typeface="Segoe UI"/>
+              </a:rPr>
+              <a:t>PID-0001  ·  ToAnnotate  ·  site PlantA  ·  unit U100</a:t>
+            </a:r>
+          </a:p>
+        </p:txBody>
+      </p:sp>
+      <p:sp>
+        <p:nvSpPr>
+          <p:cNvPr id="23" name="Rectangle 22"/>
+          <p:cNvSpPr/>
+          <p:nvPr/>
+        </p:nvSpPr>
+        <p:spPr>
+          <a:xfrm>
+            <a:off x="4882896" y="3017520"/>
+            <a:ext cx="6729984" cy="292608"/>
+          </a:xfrm>
+          <a:prstGeom prst="rect">
+            <a:avLst/>
+          </a:prstGeom>
+          <a:solidFill>
+            <a:srgbClr val="FFFFFF"/>
+          </a:solidFill>
+          <a:ln w="12700">
+            <a:solidFill>
+              <a:srgbClr val="E2DCD2"/>
+            </a:solidFill>
+          </a:ln>
+        </p:spPr>
+        <p:style>
+          <a:lnRef idx="1">
+            <a:schemeClr val="accent1"/>
+          </a:lnRef>
+          <a:fillRef idx="3">
+            <a:schemeClr val="accent1"/>
+          </a:fillRef>
+          <a:effectRef idx="2">
+            <a:schemeClr val="accent1"/>
+          </a:effectRef>
+          <a:fontRef idx="minor">
+            <a:schemeClr val="lt1"/>
+          </a:fontRef>
+        </p:style>
+        <p:txBody>
+          <a:bodyPr rtlCol="0" anchor="ctr"/>
+          <a:lstStyle/>
+          <a:p>
+            <a:pPr algn="ctr"/>
+          </a:p>
+        </p:txBody>
+      </p:sp>
+      <p:sp>
+        <p:nvSpPr>
+          <p:cNvPr id="24" name="TextBox 23"/>
+          <p:cNvSpPr txBox="1"/>
+          <p:nvPr/>
+        </p:nvSpPr>
+        <p:spPr>
+          <a:xfrm>
+            <a:off x="4974336" y="3017520"/>
+            <a:ext cx="384048" cy="292608"/>
+          </a:xfrm>
+          <a:prstGeom prst="rect">
+            <a:avLst/>
+          </a:prstGeom>
+          <a:noFill/>
+        </p:spPr>
+        <p:txBody>
+          <a:bodyPr wrap="square" lIns="0" rIns="0" tIns="0" bIns="0" anchor="ctr"/>
+          <a:lstStyle/>
+          <a:p>
+            <a:pPr algn="l">
+              <a:spcBef>
+                <a:spcPts val="0"/>
+              </a:spcBef>
+              <a:spcAft>
+                <a:spcPts val="0"/>
+              </a:spcAft>
+            </a:pPr>
+            <a:r>
+              <a:rPr sz="1200" b="1">
+                <a:solidFill>
+                  <a:srgbClr val="0E5C52"/>
+                </a:solidFill>
+                <a:latin typeface="Segoe UI"/>
+              </a:rPr>
+              <a:t>In</a:t>
+            </a:r>
+          </a:p>
+        </p:txBody>
+      </p:sp>
+      <p:sp>
+        <p:nvSpPr>
+          <p:cNvPr id="25" name="TextBox 24"/>
+          <p:cNvSpPr txBox="1"/>
+          <p:nvPr/>
+        </p:nvSpPr>
+        <p:spPr>
+          <a:xfrm>
+            <a:off x="5394960" y="3017520"/>
+            <a:ext cx="1554480" cy="292608"/>
+          </a:xfrm>
+          <a:prstGeom prst="rect">
+            <a:avLst/>
+          </a:prstGeom>
+          <a:noFill/>
+        </p:spPr>
+        <p:txBody>
+          <a:bodyPr wrap="square" lIns="0" rIns="0" tIns="0" bIns="0" anchor="ctr"/>
+          <a:lstStyle/>
+          <a:p>
+            <a:pPr algn="l">
+              <a:spcBef>
+                <a:spcPts val="0"/>
+              </a:spcBef>
+              <a:spcAft>
+                <a:spcPts val="0"/>
+              </a:spcAft>
+            </a:pPr>
+            <a:r>
+              <a:rPr sz="1200" b="1">
+                <a:solidFill>
+                  <a:srgbClr val="1C2430"/>
+                </a:solidFill>
+                <a:latin typeface="Segoe UI"/>
+              </a:rPr>
+              <a:t>23-KA-9101</a:t>
+            </a:r>
+          </a:p>
+        </p:txBody>
+      </p:sp>
+      <p:sp>
+        <p:nvSpPr>
+          <p:cNvPr id="26" name="TextBox 25"/>
+          <p:cNvSpPr txBox="1"/>
+          <p:nvPr/>
+        </p:nvSpPr>
+        <p:spPr>
+          <a:xfrm>
+            <a:off x="6949440" y="3017520"/>
+            <a:ext cx="1737360" cy="292608"/>
+          </a:xfrm>
+          <a:prstGeom prst="rect">
+            <a:avLst/>
+          </a:prstGeom>
+          <a:noFill/>
+        </p:spPr>
+        <p:txBody>
+          <a:bodyPr wrap="square" lIns="0" rIns="0" tIns="0" bIns="0" anchor="ctr"/>
+          <a:lstStyle/>
+          <a:p>
+            <a:pPr algn="l">
+              <a:spcBef>
+                <a:spcPts val="0"/>
+              </a:spcBef>
+              <a:spcAft>
+                <a:spcPts val="0"/>
+              </a:spcAft>
+            </a:pPr>
+            <a:r>
+              <a:rPr sz="1200" b="0">
+                <a:solidFill>
+                  <a:srgbClr val="5C6570"/>
+                </a:solidFill>
+                <a:latin typeface="Segoe UI"/>
+              </a:rPr>
+              <a:t>PlantA / U100</a:t>
+            </a:r>
+          </a:p>
+        </p:txBody>
+      </p:sp>
+      <p:sp>
+        <p:nvSpPr>
+          <p:cNvPr id="27" name="TextBox 26"/>
+          <p:cNvSpPr txBox="1"/>
+          <p:nvPr/>
+        </p:nvSpPr>
+        <p:spPr>
+          <a:xfrm>
+            <a:off x="8686800" y="3017520"/>
+            <a:ext cx="2788920" cy="292608"/>
+          </a:xfrm>
+          <a:prstGeom prst="rect">
+            <a:avLst/>
+          </a:prstGeom>
+          <a:noFill/>
+        </p:spPr>
+        <p:txBody>
+          <a:bodyPr wrap="square" lIns="0" rIns="0" tIns="0" bIns="0" anchor="ctr"/>
+          <a:lstStyle/>
+          <a:p>
+            <a:pPr algn="l">
+              <a:spcBef>
+                <a:spcPts val="0"/>
+              </a:spcBef>
+              <a:spcAft>
+                <a:spcPts val="0"/>
+              </a:spcAft>
+            </a:pPr>
+            <a:r>
+              <a:rPr sz="1200" b="0">
+                <a:solidFill>
+                  <a:srgbClr val="3D4754"/>
+                </a:solidFill>
+                <a:latin typeface="Segoe UI"/>
+              </a:rPr>
+              <a:t>DetectInDiagrams</a:t>
+            </a:r>
+          </a:p>
+        </p:txBody>
+      </p:sp>
+      <p:sp>
+        <p:nvSpPr>
+          <p:cNvPr id="28" name="Rectangle 27"/>
+          <p:cNvSpPr/>
+          <p:nvPr/>
+        </p:nvSpPr>
+        <p:spPr>
+          <a:xfrm>
+            <a:off x="4882896" y="3346703"/>
+            <a:ext cx="6729984" cy="292608"/>
+          </a:xfrm>
+          <a:prstGeom prst="rect">
+            <a:avLst/>
+          </a:prstGeom>
+          <a:solidFill>
+            <a:srgbClr val="FFFFFF"/>
+          </a:solidFill>
+          <a:ln w="12700">
+            <a:solidFill>
+              <a:srgbClr val="E2DCD2"/>
+            </a:solidFill>
+          </a:ln>
+        </p:spPr>
+        <p:style>
+          <a:lnRef idx="1">
+            <a:schemeClr val="accent1"/>
+          </a:lnRef>
+          <a:fillRef idx="3">
+            <a:schemeClr val="accent1"/>
+          </a:fillRef>
+          <a:effectRef idx="2">
+            <a:schemeClr val="accent1"/>
+          </a:effectRef>
+          <a:fontRef idx="minor">
+            <a:schemeClr val="lt1"/>
+          </a:fontRef>
+        </p:style>
+        <p:txBody>
+          <a:bodyPr rtlCol="0" anchor="ctr"/>
+          <a:lstStyle/>
+          <a:p>
+            <a:pPr algn="ctr"/>
+          </a:p>
+        </p:txBody>
+      </p:sp>
+      <p:sp>
+        <p:nvSpPr>
+          <p:cNvPr id="29" name="TextBox 28"/>
+          <p:cNvSpPr txBox="1"/>
+          <p:nvPr/>
+        </p:nvSpPr>
+        <p:spPr>
+          <a:xfrm>
+            <a:off x="4974336" y="3346703"/>
+            <a:ext cx="384048" cy="292608"/>
+          </a:xfrm>
+          <a:prstGeom prst="rect">
+            <a:avLst/>
+          </a:prstGeom>
+          <a:noFill/>
+        </p:spPr>
+        <p:txBody>
+          <a:bodyPr wrap="square" lIns="0" rIns="0" tIns="0" bIns="0" anchor="ctr"/>
+          <a:lstStyle/>
+          <a:p>
+            <a:pPr algn="l">
+              <a:spcBef>
+                <a:spcPts val="0"/>
+              </a:spcBef>
+              <a:spcAft>
+                <a:spcPts val="0"/>
+              </a:spcAft>
+            </a:pPr>
+            <a:r>
+              <a:rPr sz="1200" b="1">
+                <a:solidFill>
+                  <a:srgbClr val="0E5C52"/>
+                </a:solidFill>
+                <a:latin typeface="Segoe UI"/>
+              </a:rPr>
+              <a:t>In</a:t>
+            </a:r>
+          </a:p>
+        </p:txBody>
+      </p:sp>
+      <p:sp>
+        <p:nvSpPr>
+          <p:cNvPr id="30" name="TextBox 29"/>
+          <p:cNvSpPr txBox="1"/>
+          <p:nvPr/>
+        </p:nvSpPr>
+        <p:spPr>
+          <a:xfrm>
+            <a:off x="5394960" y="3346703"/>
+            <a:ext cx="1554480" cy="292608"/>
+          </a:xfrm>
+          <a:prstGeom prst="rect">
+            <a:avLst/>
+          </a:prstGeom>
+          <a:noFill/>
+        </p:spPr>
+        <p:txBody>
+          <a:bodyPr wrap="square" lIns="0" rIns="0" tIns="0" bIns="0" anchor="ctr"/>
+          <a:lstStyle/>
+          <a:p>
+            <a:pPr algn="l">
+              <a:spcBef>
+                <a:spcPts val="0"/>
+              </a:spcBef>
+              <a:spcAft>
+                <a:spcPts val="0"/>
+              </a:spcAft>
+            </a:pPr>
+            <a:r>
+              <a:rPr sz="1200" b="1">
+                <a:solidFill>
+                  <a:srgbClr val="1C2430"/>
+                </a:solidFill>
+                <a:latin typeface="Segoe UI"/>
+              </a:rPr>
+              <a:t>PA-FLARE-01</a:t>
+            </a:r>
+          </a:p>
+        </p:txBody>
+      </p:sp>
+      <p:sp>
+        <p:nvSpPr>
+          <p:cNvPr id="31" name="TextBox 30"/>
+          <p:cNvSpPr txBox="1"/>
+          <p:nvPr/>
+        </p:nvSpPr>
+        <p:spPr>
+          <a:xfrm>
+            <a:off x="6949440" y="3346703"/>
+            <a:ext cx="1737360" cy="292608"/>
+          </a:xfrm>
+          <a:prstGeom prst="rect">
+            <a:avLst/>
+          </a:prstGeom>
+          <a:noFill/>
+        </p:spPr>
+        <p:txBody>
+          <a:bodyPr wrap="square" lIns="0" rIns="0" tIns="0" bIns="0" anchor="ctr"/>
+          <a:lstStyle/>
+          <a:p>
+            <a:pPr algn="l">
+              <a:spcBef>
+                <a:spcPts val="0"/>
+              </a:spcBef>
+              <a:spcAft>
+                <a:spcPts val="0"/>
+              </a:spcAft>
+            </a:pPr>
+            <a:r>
+              <a:rPr sz="1200" b="0">
+                <a:solidFill>
+                  <a:srgbClr val="5C6570"/>
+                </a:solidFill>
+                <a:latin typeface="Segoe UI"/>
+              </a:rPr>
+              <a:t>PlantA / U300</a:t>
+            </a:r>
+          </a:p>
+        </p:txBody>
+      </p:sp>
+      <p:sp>
+        <p:nvSpPr>
+          <p:cNvPr id="32" name="TextBox 31"/>
+          <p:cNvSpPr txBox="1"/>
+          <p:nvPr/>
+        </p:nvSpPr>
+        <p:spPr>
+          <a:xfrm>
+            <a:off x="8686800" y="3346703"/>
+            <a:ext cx="2788920" cy="292608"/>
+          </a:xfrm>
+          <a:prstGeom prst="rect">
+            <a:avLst/>
+          </a:prstGeom>
+          <a:noFill/>
+        </p:spPr>
+        <p:txBody>
+          <a:bodyPr wrap="square" lIns="0" rIns="0" tIns="0" bIns="0" anchor="ctr"/>
+          <a:lstStyle/>
+          <a:p>
+            <a:pPr algn="l">
+              <a:spcBef>
+                <a:spcPts val="0"/>
+              </a:spcBef>
+              <a:spcAft>
+                <a:spcPts val="0"/>
+              </a:spcAft>
+            </a:pPr>
+            <a:r>
+              <a:rPr sz="1200" b="0">
+                <a:solidFill>
+                  <a:srgbClr val="3D4754"/>
+                </a:solidFill>
+                <a:latin typeface="Segoe UI"/>
+              </a:rPr>
+              <a:t>ScopeWideDetect</a:t>
+            </a:r>
+          </a:p>
+        </p:txBody>
+      </p:sp>
+      <p:sp>
+        <p:nvSpPr>
+          <p:cNvPr id="33" name="Rectangle 32"/>
+          <p:cNvSpPr/>
+          <p:nvPr/>
+        </p:nvSpPr>
+        <p:spPr>
+          <a:xfrm>
+            <a:off x="4882896" y="3675887"/>
+            <a:ext cx="6729984" cy="292608"/>
+          </a:xfrm>
+          <a:prstGeom prst="rect">
+            <a:avLst/>
+          </a:prstGeom>
+          <a:solidFill>
+            <a:srgbClr val="F8F1DC"/>
+          </a:solidFill>
+          <a:ln w="12700">
+            <a:solidFill>
+              <a:srgbClr val="E2DCD2"/>
+            </a:solidFill>
+          </a:ln>
+        </p:spPr>
+        <p:style>
+          <a:lnRef idx="1">
+            <a:schemeClr val="accent1"/>
+          </a:lnRef>
+          <a:fillRef idx="3">
+            <a:schemeClr val="accent1"/>
+          </a:fillRef>
+          <a:effectRef idx="2">
+            <a:schemeClr val="accent1"/>
+          </a:effectRef>
+          <a:fontRef idx="minor">
+            <a:schemeClr val="lt1"/>
+          </a:fontRef>
+        </p:style>
+        <p:txBody>
+          <a:bodyPr rtlCol="0" anchor="ctr"/>
+          <a:lstStyle/>
+          <a:p>
+            <a:pPr algn="ctr"/>
+          </a:p>
+        </p:txBody>
+      </p:sp>
+      <p:sp>
+        <p:nvSpPr>
+          <p:cNvPr id="34" name="TextBox 33"/>
+          <p:cNvSpPr txBox="1"/>
+          <p:nvPr/>
+        </p:nvSpPr>
+        <p:spPr>
+          <a:xfrm>
+            <a:off x="4974336" y="3675887"/>
+            <a:ext cx="384048" cy="292608"/>
+          </a:xfrm>
+          <a:prstGeom prst="rect">
+            <a:avLst/>
+          </a:prstGeom>
+          <a:noFill/>
+        </p:spPr>
+        <p:txBody>
+          <a:bodyPr wrap="square" lIns="0" rIns="0" tIns="0" bIns="0" anchor="ctr"/>
+          <a:lstStyle/>
+          <a:p>
+            <a:pPr algn="l">
+              <a:spcBef>
+                <a:spcPts val="0"/>
+              </a:spcBef>
+              <a:spcAft>
+                <a:spcPts val="0"/>
+              </a:spcAft>
+            </a:pPr>
+            <a:r>
+              <a:rPr sz="1200" b="1">
+                <a:solidFill>
+                  <a:srgbClr val="9A451A"/>
+                </a:solidFill>
+                <a:latin typeface="Segoe UI"/>
+              </a:rPr>
+              <a:t>Out</a:t>
+            </a:r>
+          </a:p>
+        </p:txBody>
+      </p:sp>
+      <p:sp>
+        <p:nvSpPr>
+          <p:cNvPr id="35" name="TextBox 34"/>
+          <p:cNvSpPr txBox="1"/>
+          <p:nvPr/>
+        </p:nvSpPr>
+        <p:spPr>
+          <a:xfrm>
+            <a:off x="5394960" y="3675887"/>
+            <a:ext cx="1554480" cy="292608"/>
+          </a:xfrm>
+          <a:prstGeom prst="rect">
+            <a:avLst/>
+          </a:prstGeom>
+          <a:noFill/>
+        </p:spPr>
+        <p:txBody>
+          <a:bodyPr wrap="square" lIns="0" rIns="0" tIns="0" bIns="0" anchor="ctr"/>
+          <a:lstStyle/>
+          <a:p>
+            <a:pPr algn="l">
+              <a:spcBef>
+                <a:spcPts val="0"/>
+              </a:spcBef>
+              <a:spcAft>
+                <a:spcPts val="0"/>
+              </a:spcAft>
+            </a:pPr>
+            <a:r>
+              <a:rPr sz="1200" b="1">
+                <a:solidFill>
+                  <a:srgbClr val="1C2430"/>
+                </a:solidFill>
+                <a:latin typeface="Segoe UI"/>
+              </a:rPr>
+              <a:t>23-KA-9102</a:t>
+            </a:r>
+          </a:p>
+        </p:txBody>
+      </p:sp>
+      <p:sp>
+        <p:nvSpPr>
+          <p:cNvPr id="36" name="TextBox 35"/>
+          <p:cNvSpPr txBox="1"/>
+          <p:nvPr/>
+        </p:nvSpPr>
+        <p:spPr>
+          <a:xfrm>
+            <a:off x="6949440" y="3675887"/>
+            <a:ext cx="1737360" cy="292608"/>
+          </a:xfrm>
+          <a:prstGeom prst="rect">
+            <a:avLst/>
+          </a:prstGeom>
+          <a:noFill/>
+        </p:spPr>
+        <p:txBody>
+          <a:bodyPr wrap="square" lIns="0" rIns="0" tIns="0" bIns="0" anchor="ctr"/>
+          <a:lstStyle/>
+          <a:p>
+            <a:pPr algn="l">
+              <a:spcBef>
+                <a:spcPts val="0"/>
+              </a:spcBef>
+              <a:spcAft>
+                <a:spcPts val="0"/>
+              </a:spcAft>
+            </a:pPr>
+            <a:r>
+              <a:rPr sz="1200" b="0">
+                <a:solidFill>
+                  <a:srgbClr val="5C6570"/>
+                </a:solidFill>
+                <a:latin typeface="Segoe UI"/>
+              </a:rPr>
+              <a:t>PlantA / U300</a:t>
+            </a:r>
+          </a:p>
+        </p:txBody>
+      </p:sp>
+      <p:sp>
+        <p:nvSpPr>
+          <p:cNvPr id="37" name="TextBox 36"/>
+          <p:cNvSpPr txBox="1"/>
+          <p:nvPr/>
+        </p:nvSpPr>
+        <p:spPr>
+          <a:xfrm>
+            <a:off x="8686800" y="3675887"/>
+            <a:ext cx="2788920" cy="292608"/>
+          </a:xfrm>
+          <a:prstGeom prst="rect">
+            <a:avLst/>
+          </a:prstGeom>
+          <a:noFill/>
+        </p:spPr>
+        <p:txBody>
+          <a:bodyPr wrap="square" lIns="0" rIns="0" tIns="0" bIns="0" anchor="ctr"/>
+          <a:lstStyle/>
+          <a:p>
+            <a:pPr algn="l">
+              <a:spcBef>
+                <a:spcPts val="0"/>
+              </a:spcBef>
+              <a:spcAft>
+                <a:spcPts val="0"/>
+              </a:spcAft>
+            </a:pPr>
+            <a:r>
+              <a:rPr sz="1200" b="0">
+                <a:solidFill>
+                  <a:srgbClr val="3D4754"/>
+                </a:solidFill>
+                <a:latin typeface="Segoe UI"/>
+              </a:rPr>
+              <a:t>DetectInDiagrams only</a:t>
+            </a:r>
+          </a:p>
+        </p:txBody>
+      </p:sp>
+      <p:sp>
+        <p:nvSpPr>
+          <p:cNvPr id="38" name="Rectangle 37"/>
+          <p:cNvSpPr/>
+          <p:nvPr/>
+        </p:nvSpPr>
+        <p:spPr>
+          <a:xfrm>
+            <a:off x="4882896" y="4005072"/>
+            <a:ext cx="6729984" cy="292608"/>
+          </a:xfrm>
+          <a:prstGeom prst="rect">
+            <a:avLst/>
+          </a:prstGeom>
+          <a:solidFill>
+            <a:srgbClr val="F8F1DC"/>
+          </a:solidFill>
+          <a:ln w="12700">
+            <a:solidFill>
+              <a:srgbClr val="E2DCD2"/>
+            </a:solidFill>
+          </a:ln>
+        </p:spPr>
+        <p:style>
+          <a:lnRef idx="1">
+            <a:schemeClr val="accent1"/>
+          </a:lnRef>
+          <a:fillRef idx="3">
+            <a:schemeClr val="accent1"/>
+          </a:fillRef>
+          <a:effectRef idx="2">
+            <a:schemeClr val="accent1"/>
+          </a:effectRef>
+          <a:fontRef idx="minor">
+            <a:schemeClr val="lt1"/>
+          </a:fontRef>
+        </p:style>
+        <p:txBody>
+          <a:bodyPr rtlCol="0" anchor="ctr"/>
+          <a:lstStyle/>
+          <a:p>
+            <a:pPr algn="ctr"/>
+          </a:p>
+        </p:txBody>
+      </p:sp>
+      <p:sp>
+        <p:nvSpPr>
+          <p:cNvPr id="39" name="TextBox 38"/>
+          <p:cNvSpPr txBox="1"/>
+          <p:nvPr/>
+        </p:nvSpPr>
+        <p:spPr>
+          <a:xfrm>
+            <a:off x="4974336" y="4005072"/>
+            <a:ext cx="384048" cy="292608"/>
+          </a:xfrm>
+          <a:prstGeom prst="rect">
+            <a:avLst/>
+          </a:prstGeom>
+          <a:noFill/>
+        </p:spPr>
+        <p:txBody>
+          <a:bodyPr wrap="square" lIns="0" rIns="0" tIns="0" bIns="0" anchor="ctr"/>
+          <a:lstStyle/>
+          <a:p>
+            <a:pPr algn="l">
+              <a:spcBef>
+                <a:spcPts val="0"/>
+              </a:spcBef>
+              <a:spcAft>
+                <a:spcPts val="0"/>
+              </a:spcAft>
+            </a:pPr>
+            <a:r>
+              <a:rPr sz="1200" b="1">
+                <a:solidFill>
+                  <a:srgbClr val="9A451A"/>
+                </a:solidFill>
+                <a:latin typeface="Segoe UI"/>
+              </a:rPr>
+              <a:t>Out</a:t>
+            </a:r>
+          </a:p>
+        </p:txBody>
+      </p:sp>
+      <p:sp>
+        <p:nvSpPr>
+          <p:cNvPr id="40" name="TextBox 39"/>
+          <p:cNvSpPr txBox="1"/>
+          <p:nvPr/>
+        </p:nvSpPr>
+        <p:spPr>
+          <a:xfrm>
+            <a:off x="5394960" y="4005072"/>
+            <a:ext cx="1554480" cy="292608"/>
+          </a:xfrm>
+          <a:prstGeom prst="rect">
+            <a:avLst/>
+          </a:prstGeom>
+          <a:noFill/>
+        </p:spPr>
+        <p:txBody>
+          <a:bodyPr wrap="square" lIns="0" rIns="0" tIns="0" bIns="0" anchor="ctr"/>
+          <a:lstStyle/>
+          <a:p>
+            <a:pPr algn="l">
+              <a:spcBef>
+                <a:spcPts val="0"/>
+              </a:spcBef>
+              <a:spcAft>
+                <a:spcPts val="0"/>
+              </a:spcAft>
+            </a:pPr>
+            <a:r>
+              <a:rPr sz="1200" b="1">
+                <a:solidFill>
+                  <a:srgbClr val="1C2430"/>
+                </a:solidFill>
+                <a:latin typeface="Segoe UI"/>
+              </a:rPr>
+              <a:t>45-PB-2001</a:t>
+            </a:r>
+          </a:p>
+        </p:txBody>
+      </p:sp>
+      <p:sp>
+        <p:nvSpPr>
+          <p:cNvPr id="41" name="TextBox 40"/>
+          <p:cNvSpPr txBox="1"/>
+          <p:nvPr/>
+        </p:nvSpPr>
+        <p:spPr>
+          <a:xfrm>
+            <a:off x="6949440" y="4005072"/>
+            <a:ext cx="1737360" cy="292608"/>
+          </a:xfrm>
+          <a:prstGeom prst="rect">
+            <a:avLst/>
+          </a:prstGeom>
+          <a:noFill/>
+        </p:spPr>
+        <p:txBody>
+          <a:bodyPr wrap="square" lIns="0" rIns="0" tIns="0" bIns="0" anchor="ctr"/>
+          <a:lstStyle/>
+          <a:p>
+            <a:pPr algn="l">
+              <a:spcBef>
+                <a:spcPts val="0"/>
+              </a:spcBef>
+              <a:spcAft>
+                <a:spcPts val="0"/>
+              </a:spcAft>
+            </a:pPr>
+            <a:r>
+              <a:rPr sz="1200" b="0">
+                <a:solidFill>
+                  <a:srgbClr val="5C6570"/>
+                </a:solidFill>
+                <a:latin typeface="Segoe UI"/>
+              </a:rPr>
+              <a:t>PlantB / U200</a:t>
+            </a:r>
+          </a:p>
+        </p:txBody>
+      </p:sp>
+      <p:sp>
+        <p:nvSpPr>
+          <p:cNvPr id="42" name="TextBox 41"/>
+          <p:cNvSpPr txBox="1"/>
+          <p:nvPr/>
+        </p:nvSpPr>
+        <p:spPr>
+          <a:xfrm>
+            <a:off x="8686800" y="4005072"/>
+            <a:ext cx="2788920" cy="292608"/>
+          </a:xfrm>
+          <a:prstGeom prst="rect">
+            <a:avLst/>
+          </a:prstGeom>
+          <a:noFill/>
+        </p:spPr>
+        <p:txBody>
+          <a:bodyPr wrap="square" lIns="0" rIns="0" tIns="0" bIns="0" anchor="ctr"/>
+          <a:lstStyle/>
+          <a:p>
+            <a:pPr algn="l">
+              <a:spcBef>
+                <a:spcPts val="0"/>
+              </a:spcBef>
+              <a:spcAft>
+                <a:spcPts val="0"/>
+              </a:spcAft>
+            </a:pPr>
+            <a:r>
+              <a:rPr sz="1200" b="0">
+                <a:solidFill>
+                  <a:srgbClr val="3D4754"/>
+                </a:solidFill>
+                <a:latin typeface="Segoe UI"/>
+              </a:rPr>
+              <a:t>DetectInDiagrams</a:t>
+            </a:r>
+          </a:p>
+        </p:txBody>
+      </p:sp>
+      <p:sp>
+        <p:nvSpPr>
+          <p:cNvPr id="43" name="Rectangle 42"/>
+          <p:cNvSpPr/>
+          <p:nvPr/>
+        </p:nvSpPr>
+        <p:spPr>
+          <a:xfrm>
+            <a:off x="4663440" y="4572000"/>
+            <a:ext cx="7132320" cy="1828800"/>
+          </a:xfrm>
+          <a:prstGeom prst="rect">
+            <a:avLst/>
+          </a:prstGeom>
+          <a:solidFill>
+            <a:srgbClr val="F8ECE4"/>
+          </a:solidFill>
+          <a:ln w="12700">
+            <a:solidFill>
+              <a:srgbClr val="E2DCD2"/>
+            </a:solidFill>
+          </a:ln>
+        </p:spPr>
+        <p:style>
+          <a:lnRef idx="1">
+            <a:schemeClr val="accent1"/>
+          </a:lnRef>
+          <a:fillRef idx="3">
+            <a:schemeClr val="accent1"/>
+          </a:fillRef>
+          <a:effectRef idx="2">
+            <a:schemeClr val="accent1"/>
+          </a:effectRef>
+          <a:fontRef idx="minor">
+            <a:schemeClr val="lt1"/>
+          </a:fontRef>
+        </p:style>
+        <p:txBody>
+          <a:bodyPr rtlCol="0" anchor="ctr"/>
+          <a:lstStyle/>
+          <a:p>
+            <a:pPr algn="ctr"/>
+          </a:p>
+        </p:txBody>
+      </p:sp>
+      <p:sp>
+        <p:nvSpPr>
+          <p:cNvPr id="44" name="Rectangle 43"/>
+          <p:cNvSpPr/>
+          <p:nvPr/>
+        </p:nvSpPr>
+        <p:spPr>
+          <a:xfrm>
+            <a:off x="4663440" y="4572000"/>
+            <a:ext cx="73152" cy="1828800"/>
+          </a:xfrm>
+          <a:prstGeom prst="rect">
+            <a:avLst/>
+          </a:prstGeom>
+          <a:solidFill>
+            <a:srgbClr val="9A451A"/>
+          </a:solidFill>
+          <a:ln>
+            <a:noFill/>
+          </a:ln>
+        </p:spPr>
+        <p:style>
+          <a:lnRef idx="1">
+            <a:schemeClr val="accent1"/>
+          </a:lnRef>
+          <a:fillRef idx="3">
+            <a:schemeClr val="accent1"/>
+          </a:fillRef>
+          <a:effectRef idx="2">
+            <a:schemeClr val="accent1"/>
+          </a:effectRef>
+          <a:fontRef idx="minor">
+            <a:schemeClr val="lt1"/>
+          </a:fontRef>
+        </p:style>
+        <p:txBody>
+          <a:bodyPr rtlCol="0" anchor="ctr"/>
+          <a:lstStyle/>
+          <a:p>
+            <a:pPr algn="ctr"/>
+          </a:p>
+        </p:txBody>
+      </p:sp>
+      <p:sp>
+        <p:nvSpPr>
+          <p:cNvPr id="45" name="TextBox 44"/>
+          <p:cNvSpPr txBox="1"/>
+          <p:nvPr/>
+        </p:nvSpPr>
+        <p:spPr>
+          <a:xfrm>
+            <a:off x="4882896" y="4681728"/>
+            <a:ext cx="6766560" cy="1609344"/>
+          </a:xfrm>
+          <a:prstGeom prst="rect">
+            <a:avLst/>
+          </a:prstGeom>
+          <a:noFill/>
+        </p:spPr>
+        <p:txBody>
+          <a:bodyPr wrap="square" lIns="0" rIns="0" tIns="0" bIns="0" anchor="t"/>
+          <a:lstStyle/>
+          <a:p>
+            <a:pPr algn="l">
+              <a:spcBef>
+                <a:spcPts val="0"/>
+              </a:spcBef>
+              <a:spcAft>
+                <a:spcPts val="0"/>
+              </a:spcAft>
+            </a:pPr>
+            <a:r>
+              <a:rPr sz="1400" b="1">
+                <a:solidFill>
+                  <a:srgbClr val="9A451A"/>
+                </a:solidFill>
+                <a:latin typeface="Segoe UI"/>
+              </a:rPr>
+              <a:t>Promote  ·  only when filterPatternPromoteByScope is true</a:t>
+            </a:r>
+          </a:p>
+          <a:p>
+            <a:pPr algn="l">
+              <a:spcBef>
+                <a:spcPts val="400"/>
+              </a:spcBef>
+              <a:spcAft>
+                <a:spcPts val="0"/>
+              </a:spcAft>
+            </a:pPr>
+            <a:r>
+              <a:rPr sz="1200" b="0">
+                <a:solidFill>
+                  <a:srgbClr val="1C2430"/>
+                </a:solidFill>
+                <a:latin typeface="Segoe UI"/>
+              </a:rPr>
+              <a:t>Launch scoping does not limit Promote while the flag is false.</a:t>
+            </a:r>
+          </a:p>
+          <a:p>
+            <a:pPr algn="l">
+              <a:spcBef>
+                <a:spcPts val="400"/>
+              </a:spcBef>
+              <a:spcAft>
+                <a:spcPts val="0"/>
+              </a:spcAft>
+            </a:pPr>
+            <a:r>
+              <a:rPr sz="1200" b="0">
+                <a:solidFill>
+                  <a:srgbClr val="1C2430"/>
+                </a:solidFill>
+                <a:latin typeface="Segoe UI"/>
+              </a:rPr>
+              <a:t>When it is true, the alias search adds the file's values: site = PlantA, and (unit = U100 or tag ScopeWideDetect). File links use the file view; asset links use the target entity view.</a:t>
+            </a:r>
+          </a:p>
+          <a:p>
+            <a:pPr algn="l">
+              <a:spcBef>
+                <a:spcPts val="400"/>
+              </a:spcBef>
+              <a:spcAft>
+                <a:spcPts val="0"/>
+              </a:spcAft>
+            </a:pPr>
+            <a:r>
+              <a:rPr sz="1200" b="0">
+                <a:solidFill>
+                  <a:srgbClr val="1C2430"/>
+                </a:solidFill>
+                <a:latin typeface="Segoe UI"/>
+              </a:rPr>
+              <a:t>The cache key is site=PlantA|unit=U100, so a hit in one scope is not reused in another. A blank value on the file skips that property.</a:t>
+            </a:r>
+          </a:p>
+        </p:txBody>
+      </p:sp>
+      <p:sp>
+        <p:nvSpPr>
+          <p:cNvPr id="46" name="TextBox 45"/>
+          <p:cNvSpPr txBox="1"/>
+          <p:nvPr/>
+        </p:nvSpPr>
+        <p:spPr>
+          <a:xfrm>
+            <a:off x="384048" y="6565392"/>
+            <a:ext cx="9509760" cy="219456"/>
+          </a:xfrm>
+          <a:prstGeom prst="rect">
+            <a:avLst/>
+          </a:prstGeom>
+          <a:noFill/>
+        </p:spPr>
+        <p:txBody>
+          <a:bodyPr wrap="square" lIns="0" rIns="0" tIns="0" bIns="0" anchor="t"/>
+          <a:lstStyle/>
+          <a:p>
+            <a:pPr algn="l">
+              <a:spcBef>
+                <a:spcPts val="0"/>
+              </a:spcBef>
+              <a:spcAft>
+                <a:spcPts val="0"/>
+              </a:spcAft>
+            </a:pPr>
+            <a:r>
+              <a:rPr sz="1100" b="0">
+                <a:solidFill>
+                  <a:srgbClr val="5C6570"/>
+                </a:solidFill>
+                <a:latin typeface="Segoe UI"/>
+              </a:rPr>
+              <a:t>cdf_file_annotation   ·   scope chooses which tagged entities a file may match</a:t>
+            </a:r>
+          </a:p>
+        </p:txBody>
+      </p:sp>
+      <p:sp>
+        <p:nvSpPr>
+          <p:cNvPr id="47" name="TextBox 46"/>
+          <p:cNvSpPr txBox="1"/>
+          <p:nvPr/>
+        </p:nvSpPr>
+        <p:spPr>
+          <a:xfrm>
+            <a:off x="11109960" y="6565392"/>
+            <a:ext cx="731520" cy="219456"/>
+          </a:xfrm>
+          <a:prstGeom prst="rect">
+            <a:avLst/>
+          </a:prstGeom>
+          <a:noFill/>
+        </p:spPr>
+        <p:txBody>
+          <a:bodyPr wrap="square" lIns="0" rIns="0" tIns="0" bIns="0" anchor="t"/>
+          <a:lstStyle/>
+          <a:p>
+            <a:pPr algn="l">
+              <a:spcBef>
+                <a:spcPts val="0"/>
+              </a:spcBef>
+              <a:spcAft>
+                <a:spcPts val="0"/>
+              </a:spcAft>
+            </a:pPr>
+            <a:r>
+              <a:rPr sz="1100" b="0">
+                <a:solidFill>
+                  <a:srgbClr val="5C6570"/>
+                </a:solidFill>
+                <a:latin typeface="Segoe UI"/>
+              </a:rPr>
+              <a:t>5 / 5</a:t>
             </a:r>
           </a:p>
         </p:txBody>

</xml_diff>